<commit_message>
Move Naive Bayes training into task scripts
</commit_message>
<xml_diff>
--- a/slides/AIMiniProject_presentation.pptx
+++ b/slides/AIMiniProject_presentation.pptx
@@ -5550,10 +5550,7 @@
               </a:defRPr>
             </a:pPr>
             <a:r>
-              <a:rPr>
-                <a:latin typeface="Arial"/>
-              </a:rPr>
-              <a:t>• Cài baseline Naive Bayes từ đầu trong src/baseline_naive_bayes.py.</a:t>
+              <a:t>• Cài thuật toán Naive Bayes từ đầu trong src/naive_bayes_model.py.</a:t>
             </a:r>
           </a:p>
           <a:p>
@@ -5566,10 +5563,7 @@
               </a:defRPr>
             </a:pPr>
             <a:r>
-              <a:rPr>
-                <a:latin typeface="Arial"/>
-              </a:rPr>
-              <a:t>• Train và so sánh mô hình trong:</a:t>
+              <a:t>• Train Naive Bayes và Linear SVM trong:</a:t>
             </a:r>
           </a:p>
           <a:p>

</xml_diff>

<commit_message>
update slide + sentiment models
</commit_message>
<xml_diff>
--- a/slides/AIMiniProject_presentation.pptx
+++ b/slides/AIMiniProject_presentation.pptx
@@ -5243,7 +5243,7 @@
 </file>
 
 <file path=ppt/slides/slide13.xml><?xml version="1.0" encoding="utf-8"?>
-<p:sld xmlns:a="http://schemas.openxmlformats.org/drawingml/2006/main" xmlns:r="http://schemas.openxmlformats.org/officeDocument/2006/relationships" xmlns:p="http://schemas.openxmlformats.org/presentationml/2006/main">
+<p:sld xmlns:a="http://schemas.openxmlformats.org/drawingml/2006/main" xmlns:ns2="http://schemas.microsoft.com/office/powerpoint/2010/main" xmlns:ns3="http://schemas.microsoft.com/office/drawing/2014/main" xmlns:p="http://schemas.openxmlformats.org/presentationml/2006/main">
   <p:cSld>
     <p:bg>
       <p:bgPr>
@@ -6185,7 +6185,7 @@
           <p:nvPr>
             <p:extLst>
               <p:ext uri="{D42A27DB-BD31-4B8C-83A1-F6EECF244321}">
-                <p14:modId xmlns:p14="http://schemas.microsoft.com/office/powerpoint/2010/main" val="547189928"/>
+                <ns2:modId val="547189928"/>
               </p:ext>
             </p:extLst>
           </p:nvPr>
@@ -6204,28 +6204,28 @@
                 <a:gridCol w="1143000">
                   <a:extLst>
                     <a:ext uri="{9D8B030D-6E8A-4147-A177-3AD203B41FA5}">
-                      <a16:colId xmlns:a16="http://schemas.microsoft.com/office/drawing/2014/main" val="20000"/>
+                      <ns3:colId val="20000"/>
                     </a:ext>
                   </a:extLst>
                 </a:gridCol>
                 <a:gridCol w="3063240">
                   <a:extLst>
                     <a:ext uri="{9D8B030D-6E8A-4147-A177-3AD203B41FA5}">
-                      <a16:colId xmlns:a16="http://schemas.microsoft.com/office/drawing/2014/main" val="20001"/>
+                      <ns3:colId val="20001"/>
                     </a:ext>
                   </a:extLst>
                 </a:gridCol>
                 <a:gridCol w="960120">
                   <a:extLst>
                     <a:ext uri="{9D8B030D-6E8A-4147-A177-3AD203B41FA5}">
-                      <a16:colId xmlns:a16="http://schemas.microsoft.com/office/drawing/2014/main" val="20002"/>
+                      <ns3:colId val="20002"/>
                     </a:ext>
                   </a:extLst>
                 </a:gridCol>
                 <a:gridCol w="1051560">
                   <a:extLst>
                     <a:ext uri="{9D8B030D-6E8A-4147-A177-3AD203B41FA5}">
-                      <a16:colId xmlns:a16="http://schemas.microsoft.com/office/drawing/2014/main" val="20003"/>
+                      <ns3:colId val="20003"/>
                     </a:ext>
                   </a:extLst>
                 </a:gridCol>
@@ -6335,7 +6335,7 @@
                 </a:tc>
                 <a:extLst>
                   <a:ext uri="{0D108BD9-81ED-4DB2-BD59-A6C34878D82A}">
-                    <a16:rowId xmlns:a16="http://schemas.microsoft.com/office/drawing/2014/main" val="10000"/>
+                    <ns3:rowId val="10000"/>
                   </a:ext>
                 </a:extLst>
               </a:tr>
@@ -6403,7 +6403,7 @@
                         </a:defRPr>
                       </a:pPr>
                       <a:r>
-                        <a:t>0.8318</a:t>
+                        <a:t>0.8410</a:t>
                       </a:r>
                     </a:p>
                   </a:txBody>
@@ -6427,7 +6427,7 @@
                         </a:defRPr>
                       </a:pPr>
                       <a:r>
-                        <a:t>0.7993</a:t>
+                        <a:t>0.8093</a:t>
                       </a:r>
                     </a:p>
                   </a:txBody>
@@ -6439,7 +6439,7 @@
                 </a:tc>
                 <a:extLst>
                   <a:ext uri="{0D108BD9-81ED-4DB2-BD59-A6C34878D82A}">
-                    <a16:rowId xmlns:a16="http://schemas.microsoft.com/office/drawing/2014/main" val="10001"/>
+                    <ns3:rowId val="10001"/>
                   </a:ext>
                 </a:extLst>
               </a:tr>
@@ -6543,7 +6543,7 @@
                 </a:tc>
                 <a:extLst>
                   <a:ext uri="{0D108BD9-81ED-4DB2-BD59-A6C34878D82A}">
-                    <a16:rowId xmlns:a16="http://schemas.microsoft.com/office/drawing/2014/main" val="10002"/>
+                    <ns3:rowId val="10002"/>
                   </a:ext>
                 </a:extLst>
               </a:tr>
@@ -6647,7 +6647,7 @@
                 </a:tc>
                 <a:extLst>
                   <a:ext uri="{0D108BD9-81ED-4DB2-BD59-A6C34878D82A}">
-                    <a16:rowId xmlns:a16="http://schemas.microsoft.com/office/drawing/2014/main" val="10003"/>
+                    <ns3:rowId val="10003"/>
                   </a:ext>
                 </a:extLst>
               </a:tr>
@@ -6753,7 +6753,7 @@
                 </a:tc>
                 <a:extLst>
                   <a:ext uri="{0D108BD9-81ED-4DB2-BD59-A6C34878D82A}">
-                    <a16:rowId xmlns:a16="http://schemas.microsoft.com/office/drawing/2014/main" val="10004"/>
+                    <ns3:rowId val="10004"/>
                   </a:ext>
                 </a:extLst>
               </a:tr>
@@ -6916,7 +6916,7 @@
 </file>
 
 <file path=ppt/slides/slide14.xml><?xml version="1.0" encoding="utf-8"?>
-<p:sld xmlns:a="http://schemas.openxmlformats.org/drawingml/2006/main" xmlns:r="http://schemas.openxmlformats.org/officeDocument/2006/relationships" xmlns:p="http://schemas.openxmlformats.org/presentationml/2006/main">
+<p:sld xmlns:a="http://schemas.openxmlformats.org/drawingml/2006/main" xmlns:p="http://schemas.openxmlformats.org/presentationml/2006/main" xmlns:r="http://schemas.openxmlformats.org/officeDocument/2006/relationships">
   <p:cSld>
     <p:bg>
       <p:bgPr>
@@ -7200,7 +7200,7 @@
                 </a:solidFill>
                 <a:latin typeface="Arial"/>
               </a:rPr>
-              <a:t>0.8318</a:t>
+              <a:t>0.8410</a:t>
             </a:r>
           </a:p>
         </p:txBody>
@@ -7316,7 +7316,7 @@
                 </a:solidFill>
                 <a:latin typeface="Arial"/>
               </a:rPr>
-              <a:t>0.7993</a:t>
+              <a:t>0.8093</a:t>
             </a:r>
           </a:p>
         </p:txBody>
@@ -7503,7 +7503,7 @@
               <a:rPr>
                 <a:latin typeface="Arial"/>
               </a:rPr>
-              <a:t>• neutral: 0.66</a:t>
+              <a:t>• neutral: 0.67</a:t>
             </a:r>
           </a:p>
           <a:p>
@@ -7519,7 +7519,7 @@
               <a:rPr>
                 <a:latin typeface="Arial"/>
               </a:rPr>
-              <a:t>• positive: 0.85</a:t>
+              <a:t>• positive: 0.86</a:t>
             </a:r>
           </a:p>
           <a:p>
@@ -9935,7 +9935,7 @@
           <a:p>
             <a:pPr algn="l"/>
             <a:r>
-              <a:rPr lang="vi-VN" sz="2100" b="1" dirty="0">
+              <a:rPr lang="vi-VN" sz="2100" dirty="0">
                 <a:solidFill>
                   <a:srgbClr val="142A41"/>
                 </a:solidFill>
@@ -9943,7 +9943,7 @@
               </a:rPr>
               <a:t>Giao hàng nhanh, đóng gói cũng đc tuy nhiên ốp bị ố ở viền , k lau sạch được ! Ốp cũng k ôm hết máy ! Bửa nhẹ phần viền để ốp máy vào thì bung! Hơi thất vọng!</a:t>
             </a:r>
-            <a:endParaRPr sz="2100" b="1" dirty="0">
+            <a:endParaRPr sz="2100" dirty="0">
               <a:solidFill>
                 <a:srgbClr val="142A41"/>
               </a:solidFill>
@@ -11327,7 +11327,7 @@
 </file>
 
 <file path=ppt/slides/slide2.xml><?xml version="1.0" encoding="utf-8"?>
-<p:sld xmlns:a="http://schemas.openxmlformats.org/drawingml/2006/main" xmlns:r="http://schemas.openxmlformats.org/officeDocument/2006/relationships" xmlns:p="http://schemas.openxmlformats.org/presentationml/2006/main">
+<p:sld xmlns:a="http://schemas.openxmlformats.org/drawingml/2006/main" xmlns:p="http://schemas.openxmlformats.org/presentationml/2006/main">
   <p:cSld>
     <p:bg>
       <p:bgPr>
@@ -12206,7 +12206,7 @@
               <a:rPr dirty="0">
                 <a:latin typeface="Arial"/>
               </a:rPr>
-              <a:t>: sentiment Accuracy 0.8318 / Macro F1 0.7993; issue Accuracy 0.7849 / Macro F1 0.7323.</a:t>
+              <a:t>: sentiment Accuracy 0.8410 / Macro F1 0.8093; issue Accuracy 0.7849 / Macro F1 0.7323.</a:t>
             </a:r>
           </a:p>
         </p:txBody>

</xml_diff>